<commit_message>
Add logframe and riskiest-assumptions slides to NSF working-session deck
Logframe (goal, purpose, outputs, activities with indicators, means of
verification and risk-rated assumptions) plus a slide on the five
assumptions to test or watch, placed before the asks so each ask is
tied to the risk it retires. Playbook agenda updated for new slide
numbers.

Co-Authored-By: Claude Opus 5.5 <noreply@anthropic.com>
Claude-Session: https://claude.ai/code/session_01F9J1ELsrZLDJ1adPrePgx8
</commit_message>
<xml_diff>
--- a/oi-framework/nsf/NSF-Quantum-Algorithms-Challenge_Delivery-Playbook-INTERNAL.pptx
+++ b/oi-framework/nsf/NSF-Quantum-Algorithms-Challenge_Delivery-Playbook-INTERNAL.pptx
@@ -119,19 +119,19 @@
   <p:extLst>
     <p:ext uri="{521415D9-36F7-43E2-AB2F-B90AF26B5E84}">
       <p14:sectionLst xmlns:p14="http://schemas.microsoft.com/office/powerpoint/2010/main">
-        <p14:section name="Overview" id="{257fb3a1-9f9f-2442-e632-0971cfc2d7eb}">
+        <p14:section name="Overview" id="{7e5f5dcd-03d6-abac-08cc-30f72ad86498}">
           <p14:sldIdLst>
             <p14:sldId id="256"/>
             <p14:sldId id="257"/>
           </p14:sldIdLst>
         </p14:section>
-        <p14:section name="Traceability" id="{e411736e-71e4-7e86-5247-09e2f914f95a}">
+        <p14:section name="Traceability" id="{1647f094-0d62-8528-cdd2-467248b8fe1d}">
           <p14:sldIdLst>
             <p14:sldId id="258"/>
             <p14:sldId id="259"/>
           </p14:sldIdLst>
         </p14:section>
-        <p14:section name="Tools applied" id="{8217fb3b-9cdb-2ad6-85ae-4a2ad25b411f}">
+        <p14:section name="Tools applied" id="{cb0bcb60-c646-d48b-8c86-650a66ae2548}">
           <p14:sldIdLst>
             <p14:sldId id="260"/>
             <p14:sldId id="261"/>
@@ -139,13 +139,13 @@
             <p14:sldId id="263"/>
           </p14:sldIdLst>
         </p14:section>
-        <p14:section name="Risks and KPIs" id="{d287930d-3a03-e242-ec05-38a5c64e37d5}">
+        <p14:section name="Risks and KPIs" id="{f3052eec-ebf0-f29a-045a-1a4936225b2e}">
           <p14:sldIdLst>
             <p14:sldId id="264"/>
             <p14:sldId id="265"/>
           </p14:sldIdLst>
         </p14:section>
-        <p14:section name="Next week" id="{3a7fcd11-e9e7-02db-0294-d6a0defab043}">
+        <p14:section name="Next week" id="{db08ca84-61e9-3086-003f-26c8d3025b3b}">
           <p14:sldIdLst>
             <p14:sldId id="266"/>
             <p14:sldId id="267"/>
@@ -5785,7 +5785,7 @@
                             <a:schemeClr val="tx1"/>
                           </a:solidFill>
                         </a:rPr>
-                        <a:t>65–80</a:t>
+                        <a:t>65–75</a:t>
                       </a:r>
                       <a:endParaRPr lang="en-US" sz="1450" dirty="0"/>
                     </a:p>
@@ -5846,7 +5846,7 @@
                             <a:schemeClr val="tx1"/>
                           </a:solidFill>
                         </a:rPr>
-                        <a:t>42–52</a:t>
+                        <a:t>42–48</a:t>
                       </a:r>
                       <a:endParaRPr lang="en-US" sz="1450" dirty="0"/>
                     </a:p>
@@ -6092,7 +6092,7 @@
                             <a:schemeClr val="tx1"/>
                           </a:solidFill>
                         </a:rPr>
-                        <a:t>80–90</a:t>
+                        <a:t>75–82</a:t>
                       </a:r>
                       <a:endParaRPr lang="en-US" sz="1450" dirty="0"/>
                     </a:p>
@@ -6153,7 +6153,7 @@
                             <a:schemeClr val="tx1"/>
                           </a:solidFill>
                         </a:rPr>
-                        <a:t>52–60</a:t>
+                        <a:t>48–53</a:t>
                       </a:r>
                       <a:endParaRPr lang="en-US" sz="1450" dirty="0"/>
                     </a:p>
@@ -6214,6 +6214,313 @@
                             <a:schemeClr val="tx1"/>
                           </a:solidFill>
                         </a:rPr>
+                        <a:t>Logframe and riskiest assumptions</a:t>
+                      </a:r>
+                      <a:endParaRPr lang="en-US" sz="1450" dirty="0"/>
+                    </a:p>
+                  </a:txBody>
+                  <a:tcPr marL="76200" marR="76200" marT="50800" marB="50800" anchor="t">
+                    <a:lnL w="6350" cap="flat" cmpd="sng" algn="ctr">
+                      <a:solidFill>
+                        <a:srgbClr val="BFE0D8"/>
+                      </a:solidFill>
+                      <a:prstDash val="solid"/>
+                      <a:round/>
+                      <a:headEnd type="none" w="med" len="med"/>
+                      <a:tailEnd type="none" w="med" len="med"/>
+                    </a:lnL>
+                    <a:lnR w="6350" cap="flat" cmpd="sng" algn="ctr">
+                      <a:solidFill>
+                        <a:srgbClr val="BFE0D8"/>
+                      </a:solidFill>
+                      <a:prstDash val="solid"/>
+                      <a:round/>
+                      <a:headEnd type="none" w="med" len="med"/>
+                      <a:tailEnd type="none" w="med" len="med"/>
+                    </a:lnR>
+                    <a:lnT w="6350" cap="flat" cmpd="sng" algn="ctr">
+                      <a:solidFill>
+                        <a:srgbClr val="BFE0D8"/>
+                      </a:solidFill>
+                      <a:prstDash val="solid"/>
+                      <a:round/>
+                      <a:headEnd type="none" w="med" len="med"/>
+                      <a:tailEnd type="none" w="med" len="med"/>
+                    </a:lnT>
+                    <a:lnB w="6350" cap="flat" cmpd="sng" algn="ctr">
+                      <a:solidFill>
+                        <a:srgbClr val="BFE0D8"/>
+                      </a:solidFill>
+                      <a:prstDash val="solid"/>
+                      <a:round/>
+                      <a:headEnd type="none" w="med" len="med"/>
+                      <a:tailEnd type="none" w="med" len="med"/>
+                    </a:lnB>
+                    <a:solidFill>
+                      <a:schemeClr val="bg1"/>
+                    </a:solidFill>
+                  </a:tcPr>
+                </a:tc>
+                <a:tc>
+                  <a:txBody>
+                    <a:bodyPr/>
+                    <a:lstStyle/>
+                    <a:p>
+                      <a:pPr indent="0" marL="0">
+                        <a:buNone/>
+                      </a:pPr>
+                      <a:r>
+                        <a:rPr lang="en-US" sz="1450" dirty="0">
+                          <a:solidFill>
+                            <a:schemeClr val="tx1"/>
+                          </a:solidFill>
+                        </a:rPr>
+                        <a:t>Point only to the assumptions column; ask the room which risk worries them most</a:t>
+                      </a:r>
+                      <a:endParaRPr lang="en-US" sz="1450" dirty="0"/>
+                    </a:p>
+                  </a:txBody>
+                  <a:tcPr marL="76200" marR="76200" marT="50800" marB="50800" anchor="t">
+                    <a:lnL w="6350" cap="flat" cmpd="sng" algn="ctr">
+                      <a:solidFill>
+                        <a:srgbClr val="BFE0D8"/>
+                      </a:solidFill>
+                      <a:prstDash val="solid"/>
+                      <a:round/>
+                      <a:headEnd type="none" w="med" len="med"/>
+                      <a:tailEnd type="none" w="med" len="med"/>
+                    </a:lnL>
+                    <a:lnR w="6350" cap="flat" cmpd="sng" algn="ctr">
+                      <a:solidFill>
+                        <a:srgbClr val="BFE0D8"/>
+                      </a:solidFill>
+                      <a:prstDash val="solid"/>
+                      <a:round/>
+                      <a:headEnd type="none" w="med" len="med"/>
+                      <a:tailEnd type="none" w="med" len="med"/>
+                    </a:lnR>
+                    <a:lnT w="6350" cap="flat" cmpd="sng" algn="ctr">
+                      <a:solidFill>
+                        <a:srgbClr val="BFE0D8"/>
+                      </a:solidFill>
+                      <a:prstDash val="solid"/>
+                      <a:round/>
+                      <a:headEnd type="none" w="med" len="med"/>
+                      <a:tailEnd type="none" w="med" len="med"/>
+                    </a:lnT>
+                    <a:lnB w="6350" cap="flat" cmpd="sng" algn="ctr">
+                      <a:solidFill>
+                        <a:srgbClr val="BFE0D8"/>
+                      </a:solidFill>
+                      <a:prstDash val="solid"/>
+                      <a:round/>
+                      <a:headEnd type="none" w="med" len="med"/>
+                      <a:tailEnd type="none" w="med" len="med"/>
+                    </a:lnB>
+                    <a:solidFill>
+                      <a:schemeClr val="bg1"/>
+                    </a:solidFill>
+                  </a:tcPr>
+                </a:tc>
+                <a:tc>
+                  <a:txBody>
+                    <a:bodyPr/>
+                    <a:lstStyle/>
+                    <a:p>
+                      <a:pPr indent="0" marL="0">
+                        <a:buNone/>
+                      </a:pPr>
+                      <a:r>
+                        <a:rPr lang="en-US" sz="1450" dirty="0">
+                          <a:solidFill>
+                            <a:schemeClr val="tx1"/>
+                          </a:solidFill>
+                        </a:rPr>
+                        <a:t>13–14</a:t>
+                      </a:r>
+                      <a:endParaRPr lang="en-US" sz="1450" dirty="0"/>
+                    </a:p>
+                  </a:txBody>
+                  <a:tcPr marL="76200" marR="76200" marT="50800" marB="50800" anchor="t">
+                    <a:lnL w="6350" cap="flat" cmpd="sng" algn="ctr">
+                      <a:solidFill>
+                        <a:srgbClr val="BFE0D8"/>
+                      </a:solidFill>
+                      <a:prstDash val="solid"/>
+                      <a:round/>
+                      <a:headEnd type="none" w="med" len="med"/>
+                      <a:tailEnd type="none" w="med" len="med"/>
+                    </a:lnL>
+                    <a:lnR w="6350" cap="flat" cmpd="sng" algn="ctr">
+                      <a:solidFill>
+                        <a:srgbClr val="BFE0D8"/>
+                      </a:solidFill>
+                      <a:prstDash val="solid"/>
+                      <a:round/>
+                      <a:headEnd type="none" w="med" len="med"/>
+                      <a:tailEnd type="none" w="med" len="med"/>
+                    </a:lnR>
+                    <a:lnT w="6350" cap="flat" cmpd="sng" algn="ctr">
+                      <a:solidFill>
+                        <a:srgbClr val="BFE0D8"/>
+                      </a:solidFill>
+                      <a:prstDash val="solid"/>
+                      <a:round/>
+                      <a:headEnd type="none" w="med" len="med"/>
+                      <a:tailEnd type="none" w="med" len="med"/>
+                    </a:lnT>
+                    <a:lnB w="6350" cap="flat" cmpd="sng" algn="ctr">
+                      <a:solidFill>
+                        <a:srgbClr val="BFE0D8"/>
+                      </a:solidFill>
+                      <a:prstDash val="solid"/>
+                      <a:round/>
+                      <a:headEnd type="none" w="med" len="med"/>
+                      <a:tailEnd type="none" w="med" len="med"/>
+                    </a:lnB>
+                    <a:solidFill>
+                      <a:schemeClr val="bg1"/>
+                    </a:solidFill>
+                  </a:tcPr>
+                </a:tc>
+              </a:tr>
+              <a:tr h="0">
+                <a:tc>
+                  <a:txBody>
+                    <a:bodyPr/>
+                    <a:lstStyle/>
+                    <a:p>
+                      <a:pPr indent="0" marL="0">
+                        <a:buNone/>
+                      </a:pPr>
+                      <a:r>
+                        <a:rPr lang="en-US" sz="1450" dirty="0">
+                          <a:solidFill>
+                            <a:schemeClr val="tx1"/>
+                          </a:solidFill>
+                        </a:rPr>
+                        <a:t>82–90</a:t>
+                      </a:r>
+                      <a:endParaRPr lang="en-US" sz="1450" dirty="0"/>
+                    </a:p>
+                  </a:txBody>
+                  <a:tcPr marL="76200" marR="76200" marT="50800" marB="50800" anchor="t">
+                    <a:lnL w="6350" cap="flat" cmpd="sng" algn="ctr">
+                      <a:solidFill>
+                        <a:srgbClr val="BFE0D8"/>
+                      </a:solidFill>
+                      <a:prstDash val="solid"/>
+                      <a:round/>
+                      <a:headEnd type="none" w="med" len="med"/>
+                      <a:tailEnd type="none" w="med" len="med"/>
+                    </a:lnL>
+                    <a:lnR w="6350" cap="flat" cmpd="sng" algn="ctr">
+                      <a:solidFill>
+                        <a:srgbClr val="BFE0D8"/>
+                      </a:solidFill>
+                      <a:prstDash val="solid"/>
+                      <a:round/>
+                      <a:headEnd type="none" w="med" len="med"/>
+                      <a:tailEnd type="none" w="med" len="med"/>
+                    </a:lnR>
+                    <a:lnT w="6350" cap="flat" cmpd="sng" algn="ctr">
+                      <a:solidFill>
+                        <a:srgbClr val="BFE0D8"/>
+                      </a:solidFill>
+                      <a:prstDash val="solid"/>
+                      <a:round/>
+                      <a:headEnd type="none" w="med" len="med"/>
+                      <a:tailEnd type="none" w="med" len="med"/>
+                    </a:lnT>
+                    <a:lnB w="6350" cap="flat" cmpd="sng" algn="ctr">
+                      <a:solidFill>
+                        <a:srgbClr val="BFE0D8"/>
+                      </a:solidFill>
+                      <a:prstDash val="solid"/>
+                      <a:round/>
+                      <a:headEnd type="none" w="med" len="med"/>
+                      <a:tailEnd type="none" w="med" len="med"/>
+                    </a:lnB>
+                    <a:solidFill>
+                      <a:schemeClr val="bg2"/>
+                    </a:solidFill>
+                  </a:tcPr>
+                </a:tc>
+                <a:tc>
+                  <a:txBody>
+                    <a:bodyPr/>
+                    <a:lstStyle/>
+                    <a:p>
+                      <a:pPr indent="0" marL="0">
+                        <a:buNone/>
+                      </a:pPr>
+                      <a:r>
+                        <a:rPr lang="en-US" sz="1450" dirty="0">
+                          <a:solidFill>
+                            <a:schemeClr val="tx1"/>
+                          </a:solidFill>
+                        </a:rPr>
+                        <a:t>53–60</a:t>
+                      </a:r>
+                      <a:endParaRPr lang="en-US" sz="1450" dirty="0"/>
+                    </a:p>
+                  </a:txBody>
+                  <a:tcPr marL="76200" marR="76200" marT="50800" marB="50800" anchor="t">
+                    <a:lnL w="6350" cap="flat" cmpd="sng" algn="ctr">
+                      <a:solidFill>
+                        <a:srgbClr val="BFE0D8"/>
+                      </a:solidFill>
+                      <a:prstDash val="solid"/>
+                      <a:round/>
+                      <a:headEnd type="none" w="med" len="med"/>
+                      <a:tailEnd type="none" w="med" len="med"/>
+                    </a:lnL>
+                    <a:lnR w="6350" cap="flat" cmpd="sng" algn="ctr">
+                      <a:solidFill>
+                        <a:srgbClr val="BFE0D8"/>
+                      </a:solidFill>
+                      <a:prstDash val="solid"/>
+                      <a:round/>
+                      <a:headEnd type="none" w="med" len="med"/>
+                      <a:tailEnd type="none" w="med" len="med"/>
+                    </a:lnR>
+                    <a:lnT w="6350" cap="flat" cmpd="sng" algn="ctr">
+                      <a:solidFill>
+                        <a:srgbClr val="BFE0D8"/>
+                      </a:solidFill>
+                      <a:prstDash val="solid"/>
+                      <a:round/>
+                      <a:headEnd type="none" w="med" len="med"/>
+                      <a:tailEnd type="none" w="med" len="med"/>
+                    </a:lnT>
+                    <a:lnB w="6350" cap="flat" cmpd="sng" algn="ctr">
+                      <a:solidFill>
+                        <a:srgbClr val="BFE0D8"/>
+                      </a:solidFill>
+                      <a:prstDash val="solid"/>
+                      <a:round/>
+                      <a:headEnd type="none" w="med" len="med"/>
+                      <a:tailEnd type="none" w="med" len="med"/>
+                    </a:lnB>
+                    <a:solidFill>
+                      <a:schemeClr val="bg2"/>
+                    </a:solidFill>
+                  </a:tcPr>
+                </a:tc>
+                <a:tc>
+                  <a:txBody>
+                    <a:bodyPr/>
+                    <a:lstStyle/>
+                    <a:p>
+                      <a:pPr indent="0" marL="0">
+                        <a:buNone/>
+                      </a:pPr>
+                      <a:r>
+                        <a:rPr lang="en-US" sz="1450" dirty="0">
+                          <a:solidFill>
+                            <a:schemeClr val="tx1"/>
+                          </a:solidFill>
+                        </a:rPr>
                         <a:t>Asks, decisions, next 90 days</a:t>
                       </a:r>
                       <a:endParaRPr lang="en-US" sz="1450" dirty="0"/>
@@ -6257,7 +6564,7 @@
                       <a:tailEnd type="none" w="med" len="med"/>
                     </a:lnB>
                     <a:solidFill>
-                      <a:schemeClr val="bg1"/>
+                      <a:schemeClr val="bg2"/>
                     </a:solidFill>
                   </a:tcPr>
                 </a:tc>
@@ -6318,7 +6625,7 @@
                       <a:tailEnd type="none" w="med" len="med"/>
                     </a:lnB>
                     <a:solidFill>
-                      <a:schemeClr val="bg1"/>
+                      <a:schemeClr val="bg2"/>
                     </a:solidFill>
                   </a:tcPr>
                 </a:tc>
@@ -6336,7 +6643,7 @@
                             <a:schemeClr val="tx1"/>
                           </a:solidFill>
                         </a:rPr>
-                        <a:t>13–15</a:t>
+                        <a:t>15–17</a:t>
                       </a:r>
                       <a:endParaRPr lang="en-US" sz="1450" dirty="0"/>
                     </a:p>
@@ -6379,7 +6686,7 @@
                       <a:tailEnd type="none" w="med" len="med"/>
                     </a:lnB>
                     <a:solidFill>
-                      <a:schemeClr val="bg1"/>
+                      <a:schemeClr val="bg2"/>
                     </a:solidFill>
                   </a:tcPr>
                 </a:tc>

</xml_diff>